<commit_message>
Deck: test counts 83/83 offline and 13 live; root cause is Gemini over ticket history, search feeds the interview
Co-Authored-By: Claude Opus 5.5 <noreply@anthropic.com>
</commit_message>
<xml_diff>
--- a/Human_in_the_loop_Policy_Vault_AI_Builder_Cup.pptx
+++ b/Human_in_the_loop_Policy_Vault_AI_Builder_Cup.pptx
@@ -10342,7 +10342,7 @@
                 <a:cs typeface="Google Sans Flex SemiBold"/>
                 <a:sym typeface="Google Sans Flex SemiBold"/>
               </a:rPr>
-              <a:t xml:space="preserve">64 / 64 </a:t>
+              <a:t xml:space="preserve">83 / 83 </a:t>
             </a:r>
             <a:r>
               <a:rPr lang="en-GB" sz="950" dirty="0">
@@ -10377,7 +10377,7 @@
                 <a:cs typeface="Google Sans Flex SemiBold"/>
                 <a:sym typeface="Google Sans Flex SemiBold"/>
               </a:rPr>
-              <a:t xml:space="preserve">9 / 9 </a:t>
+              <a:t xml:space="preserve">13 / 13 </a:t>
             </a:r>
             <a:r>
               <a:rPr lang="en-GB" sz="950" dirty="0">
@@ -17001,7 +17001,7 @@
                 <a:cs typeface="Google Sans Flex"/>
                 <a:sym typeface="Google Sans Flex"/>
               </a:rPr>
-              <a:t>Gemini + Vertex AI Search find the root-cause ticket</a:t>
+              <a:t>Gemini reads the ticket history and names the root-cause ticket</a:t>
             </a:r>
           </a:p>
         </p:txBody>
@@ -17384,7 +17384,7 @@
                 <a:cs typeface="Google Sans Flex"/>
                 <a:sym typeface="Google Sans Flex"/>
               </a:rPr>
-              <a:t>Evidence-led question with date clues</a:t>
+              <a:t>Evidence-led question with Vertex AI Search and date clues</a:t>
             </a:r>
           </a:p>
         </p:txBody>
@@ -21361,7 +21361,7 @@
                 <a:cs typeface="Google Sans Flex"/>
                 <a:sym typeface="Google Sans Flex"/>
               </a:rPr>
-              <a:t>Flask, google-genai SDK, Discovery Engine and Firestore clients, pytest: 64 offline tests and 9 live end-to-end checks.</a:t>
+              <a:t>Flask, google-genai SDK, Discovery Engine and Firestore clients, pytest: 83 offline tests and 13 live end-to-end checks.</a:t>
             </a:r>
           </a:p>
         </p:txBody>

</xml_diff>